<commit_message>
feat: IRCTC-style Train Search redesign with 3-screen flow (Search Form, Results List, Detail View) + removed header search bar
</commit_message>
<xml_diff>
--- a/presentation/AUTONEX_SIH.pptx
+++ b/presentation/AUTONEX_SIH.pptx
@@ -3108,8 +3108,8 @@
         </p:nvSpPr>
         <p:spPr>
           <a:xfrm>
-            <a:off x="731520" y="365760"/>
-            <a:ext cx="10698480" cy="1371600"/>
+            <a:off x="731520" y="274320"/>
+            <a:ext cx="10698480" cy="1188720"/>
           </a:xfrm>
           <a:prstGeom prst="rect">
             <a:avLst/>
@@ -3123,7 +3123,7 @@
           <a:lstStyle/>
           <a:p>
             <a:pPr>
-              <a:defRPr sz="3600" b="1">
+              <a:defRPr sz="3200" b="1">
                 <a:solidFill>
                   <a:srgbClr val="06B6D4"/>
                 </a:solidFill>
@@ -3136,7 +3136,7 @@
           </a:p>
           <a:p>
             <a:pPr>
-              <a:defRPr sz="1800" b="1">
+              <a:defRPr sz="1600" b="1">
                 <a:solidFill>
                   <a:srgbClr val="FFFFFF"/>
                 </a:solidFill>
@@ -3144,12 +3144,12 @@
               </a:defRPr>
             </a:pPr>
             <a:r>
-              <a:t>Dynamic Forecast of Expected Time of Arrival (ETA) for Coaching Trains</a:t>
+              <a:t>Dynamic Forecast of Expected Time of Arrival (ETA) &amp; Safety Management for Coaching Trains</a:t>
             </a:r>
           </a:p>
           <a:p>
             <a:pPr>
-              <a:defRPr sz="1200">
+              <a:defRPr sz="1100">
                 <a:solidFill>
                   <a:srgbClr val="A0AEC0"/>
                 </a:solidFill>
@@ -3157,7 +3157,7 @@
               </a:defRPr>
             </a:pPr>
             <a:r>
-              <a:t>Smart India Hackathon (SIH) | Intelligent Traffic &amp; Delay Management System</a:t>
+              <a:t>Smart India Hackathon (SIH) | Intelligent Multi-Sensor Traffic, Safety &amp; Maintenance System</a:t>
             </a:r>
           </a:p>
         </p:txBody>
@@ -3170,8 +3170,109 @@
         </p:nvSpPr>
         <p:spPr>
           <a:xfrm>
-            <a:off x="731520" y="1828800"/>
-            <a:ext cx="10728655" cy="1371600"/>
+            <a:off x="731520" y="1554480"/>
+            <a:ext cx="10728655" cy="2011680"/>
+          </a:xfrm>
+          <a:prstGeom prst="roundRect">
+            <a:avLst/>
+          </a:prstGeom>
+          <a:solidFill>
+            <a:srgbClr val="172544"/>
+          </a:solidFill>
+          <a:ln w="19050">
+            <a:solidFill>
+              <a:srgbClr val="F59E0B"/>
+            </a:solidFill>
+          </a:ln>
+        </p:spPr>
+        <p:style>
+          <a:lnRef idx="1">
+            <a:schemeClr val="accent1"/>
+          </a:lnRef>
+          <a:fillRef idx="3">
+            <a:schemeClr val="accent1"/>
+          </a:fillRef>
+          <a:effectRef idx="2">
+            <a:schemeClr val="accent1"/>
+          </a:effectRef>
+          <a:fontRef idx="minor">
+            <a:schemeClr val="lt1"/>
+          </a:fontRef>
+        </p:style>
+        <p:txBody>
+          <a:bodyPr rtlCol="0" anchor="ctr" wrap="square" tIns="137160" lIns="274320" rIns="274320"/>
+          <a:lstStyle/>
+          <a:p>
+            <a:pPr algn="ctr">
+              <a:defRPr sz="1100" b="1">
+                <a:solidFill>
+                  <a:srgbClr val="F59E0B"/>
+                </a:solidFill>
+                <a:latin typeface="Calibri"/>
+              </a:defRPr>
+            </a:pPr>
+            <a:r>
+              <a:t>PROBLEM STATEMENT: STUDENT INNOVATION TECHNOLOGY IDEAS IN TERTIARY SECTORS LIKE HOSPITALITY, FINANCIAL SERVICES, ENTERTAINMENT AND RETAILS</a:t>
+            </a:r>
+          </a:p>
+          <a:p>
+            <a:pPr>
+              <a:spcBef>
+                <a:spcPts val="300"/>
+              </a:spcBef>
+            </a:pPr>
+            <a:r>
+              <a:rPr b="1" sz="1050">
+                <a:solidFill>
+                  <a:srgbClr val="FFFFFF"/>
+                </a:solidFill>
+              </a:rPr>
+              <a:t>•  Cross-Sector Innovation Transfer:</a:t>
+            </a:r>
+            <a:r>
+              <a:rPr sz="1050">
+                <a:solidFill>
+                  <a:srgbClr val="A0AEC0"/>
+                </a:solidFill>
+              </a:rPr>
+              <a:t> Translating advanced data analytics, sensor telemetry, dynamic forecasting, and automated queue/resource management from tertiary service sectors into heavy railway transport logistics.</a:t>
+            </a:r>
+          </a:p>
+          <a:p>
+            <a:pPr>
+              <a:spcBef>
+                <a:spcPts val="300"/>
+              </a:spcBef>
+            </a:pPr>
+            <a:r>
+              <a:rPr b="1" sz="1050">
+                <a:solidFill>
+                  <a:srgbClr val="FFFFFF"/>
+                </a:solidFill>
+              </a:rPr>
+              <a:t>•  Operational Friction &amp; Delays:</a:t>
+            </a:r>
+            <a:r>
+              <a:rPr sz="1050">
+                <a:solidFill>
+                  <a:srgbClr val="A0AEC0"/>
+                </a:solidFill>
+              </a:rPr>
+              <a:t> Traditional transport management suffers from reactive decision-making, manual communication latency, and lack of real-time predictive visibility across complex service networks.</a:t>
+            </a:r>
+          </a:p>
+        </p:txBody>
+      </p:sp>
+      <p:sp>
+        <p:nvSpPr>
+          <p:cNvPr id="4" name="Rounded Rectangle 3"/>
+          <p:cNvSpPr/>
+          <p:nvPr/>
+        </p:nvSpPr>
+        <p:spPr>
+          <a:xfrm>
+            <a:off x="731520" y="3749039"/>
+            <a:ext cx="10728655" cy="2743200"/>
           </a:xfrm>
           <a:prstGeom prst="roundRect">
             <a:avLst/>
@@ -3200,180 +3301,111 @@
           </a:fontRef>
         </p:style>
         <p:txBody>
-          <a:bodyPr rtlCol="0" anchor="ctr" wrap="square" tIns="137160" lIns="274320"/>
+          <a:bodyPr rtlCol="0" anchor="ctr" wrap="square" tIns="137160" lIns="274320" rIns="274320"/>
           <a:lstStyle/>
           <a:p>
             <a:pPr algn="ctr">
-              <a:defRPr sz="1300" b="1">
+              <a:defRPr sz="1200" b="1">
                 <a:solidFill>
                   <a:srgbClr val="06B6D4"/>
                 </a:solidFill>
-              </a:defRPr>
-            </a:pPr>
-            <a:r>
-              <a:t>EXECUTIVE SUMMARY &amp; SYSTEM DESCRIPTION</a:t>
+                <a:latin typeface="Calibri"/>
+              </a:defRPr>
+            </a:pPr>
+            <a:r>
+              <a:t>OBJECTIVE: RAILWAY TRAFFIC BOTTLENECK ELIMINATION, MULTI-SENSOR INTEGRATION &amp; ETA FORECAST</a:t>
             </a:r>
           </a:p>
           <a:p>
             <a:pPr>
               <a:spcBef>
-                <a:spcPts val="400"/>
+                <a:spcPts val="300"/>
               </a:spcBef>
-              <a:defRPr sz="1100">
+            </a:pPr>
+            <a:r>
+              <a:rPr b="1" sz="1050">
                 <a:solidFill>
                   <a:srgbClr val="FFFFFF"/>
                 </a:solidFill>
-              </a:defRPr>
-            </a:pPr>
-            <a:r>
-              <a:t>AUTONEX is an intelligent, AI-powered traffic scheduling and real-time ETA forecasting platform designed for Indian Railways. It dynamically predicts expected arrival times for coaching trains while resolving network bottlenecks caused by delayed freight trains (maal gadi). By combining real-time gap telemetry with 20-30 minute advance loop line routing, AUTONEX eliminates cascading delays with guaranteed 0% collision risk.</a:t>
-            </a:r>
-          </a:p>
-        </p:txBody>
-      </p:sp>
-      <p:sp>
-        <p:nvSpPr>
-          <p:cNvPr id="4" name="Rounded Rectangle 3"/>
-          <p:cNvSpPr/>
-          <p:nvPr/>
-        </p:nvSpPr>
-        <p:spPr>
-          <a:xfrm>
-            <a:off x="731520" y="3383280"/>
-            <a:ext cx="10728655" cy="3017520"/>
-          </a:xfrm>
-          <a:prstGeom prst="roundRect">
-            <a:avLst/>
-          </a:prstGeom>
-          <a:solidFill>
-            <a:srgbClr val="172544"/>
-          </a:solidFill>
-          <a:ln w="19050">
-            <a:solidFill>
-              <a:srgbClr val="28416E"/>
-            </a:solidFill>
-          </a:ln>
-        </p:spPr>
-        <p:style>
-          <a:lnRef idx="1">
-            <a:schemeClr val="accent1"/>
-          </a:lnRef>
-          <a:fillRef idx="3">
-            <a:schemeClr val="accent1"/>
-          </a:fillRef>
-          <a:effectRef idx="2">
-            <a:schemeClr val="accent1"/>
-          </a:effectRef>
-          <a:fontRef idx="minor">
-            <a:schemeClr val="lt1"/>
-          </a:fontRef>
-        </p:style>
-        <p:txBody>
-          <a:bodyPr rtlCol="0" anchor="ctr" wrap="square" tIns="137160" lIns="274320" rIns="274320"/>
-          <a:lstStyle/>
-          <a:p>
-            <a:pPr algn="ctr">
-              <a:defRPr sz="1300" b="1">
-                <a:solidFill>
-                  <a:srgbClr val="F59E0B"/>
-                </a:solidFill>
-                <a:latin typeface="Calibri"/>
-              </a:defRPr>
-            </a:pPr>
-            <a:r>
-              <a:t>PROBLEM STATEMENT: DYNAMIC FORECAST OF EXPECTED TIME OF ARRIVAL (ETA) FOR COACHING TRAINS</a:t>
+              </a:rPr>
+              <a:t>•  Cascading Network Delays:</a:t>
+            </a:r>
+            <a:r>
+              <a:rPr sz="1050">
+                <a:solidFill>
+                  <a:srgbClr val="A0AEC0"/>
+                </a:solidFill>
+              </a:rPr>
+              <a:t> Freight trains (maal gadi) choke express corridors, causing massive cascading delay propagation for high-priority coaching trains.</a:t>
             </a:r>
           </a:p>
           <a:p>
             <a:pPr>
               <a:spcBef>
-                <a:spcPts val="400"/>
+                <a:spcPts val="300"/>
               </a:spcBef>
             </a:pPr>
             <a:r>
-              <a:rPr b="1" sz="1100">
+              <a:rPr b="1" sz="1050">
                 <a:solidFill>
                   <a:srgbClr val="FFFFFF"/>
                 </a:solidFill>
               </a:rPr>
-              <a:t>•  Cascading Network Delays:</a:t>
-            </a:r>
-            <a:r>
-              <a:rPr sz="1100">
+              <a:t>•  Multi-Sensor Integration (Speed, Safety &amp; Track Health):</a:t>
+            </a:r>
+            <a:r>
+              <a:rPr sz="1050">
                 <a:solidFill>
                   <a:srgbClr val="A0AEC0"/>
                 </a:solidFill>
               </a:rPr>
-              <a:t> Unscheduled freight delays block coaching trains, wrecking ETA accuracy across the route.</a:t>
+              <a:t> Deploying wheel tachometers and axle counter sensors for live train speed tracking, proximity/brake sensors for safety management, and trackside strain &amp; vibration sensors for predictive track maintenance.</a:t>
             </a:r>
           </a:p>
           <a:p>
             <a:pPr>
               <a:spcBef>
-                <a:spcPts val="400"/>
+                <a:spcPts val="300"/>
               </a:spcBef>
             </a:pPr>
             <a:r>
-              <a:rPr b="1" sz="1100">
+              <a:rPr b="1" sz="1050">
                 <a:solidFill>
                   <a:srgbClr val="FFFFFF"/>
                 </a:solidFill>
               </a:rPr>
-              <a:t>•  Massive Financial Loss:</a:t>
-            </a:r>
-            <a:r>
-              <a:rPr sz="1100">
+              <a:t>•  Pre-emptive Overtake &amp; Halt Optimization:</a:t>
+            </a:r>
+            <a:r>
+              <a:rPr sz="1050">
                 <a:solidFill>
                   <a:srgbClr val="A0AEC0"/>
                 </a:solidFill>
               </a:rPr>
-              <a:t> Heavy operational expenses, fuel wastage, and capacity drop due to uncoordinated signals.</a:t>
+              <a:t> Detecting speed deltas and distance gaps 20-30 minutes in advance to shunt freight trains into loop lines smoothly with zero collision risk.</a:t>
             </a:r>
           </a:p>
           <a:p>
             <a:pPr>
               <a:spcBef>
-                <a:spcPts val="400"/>
+                <a:spcPts val="300"/>
               </a:spcBef>
             </a:pPr>
             <a:r>
-              <a:rPr b="1" sz="1100">
+              <a:rPr b="1" sz="1050">
                 <a:solidFill>
                   <a:srgbClr val="FFFFFF"/>
                 </a:solidFill>
               </a:rPr>
-              <a:t>•  Reactive Dispatching Issue:</a:t>
-            </a:r>
-            <a:r>
-              <a:rPr sz="1100">
+              <a:t>•  Dynamic Live ETA Readout:</a:t>
+            </a:r>
+            <a:r>
+              <a:rPr sz="1050">
                 <a:solidFill>
                   <a:srgbClr val="A0AEC0"/>
                 </a:solidFill>
               </a:rPr>
-              <a:t> Decisions made late at signals rather than miles in advance cause prolonged idling.</a:t>
-            </a:r>
-          </a:p>
-          <a:p>
-            <a:pPr>
-              <a:spcBef>
-                <a:spcPts val="400"/>
-              </a:spcBef>
-            </a:pPr>
-            <a:r>
-              <a:rPr b="1" sz="1100">
-                <a:solidFill>
-                  <a:srgbClr val="FFFFFF"/>
-                </a:solidFill>
-              </a:rPr>
-              <a:t>•  Speed vs. Safety Barrier:</a:t>
-            </a:r>
-            <a:r>
-              <a:rPr sz="1100">
-                <a:solidFill>
-                  <a:srgbClr val="A0AEC0"/>
-                </a:solidFill>
-              </a:rPr>
-              <a:t> Accelerating late coaching trains manually without live gap monitoring risks collisions.</a:t>
+              <a:t> Delivering sub-second accurate ETA updates to Station Master signaling consoles and passenger screens, eliminating financial and fuel losses.</a:t>
             </a:r>
           </a:p>
         </p:txBody>
@@ -3412,7 +3444,7 @@
         </p:nvSpPr>
         <p:spPr>
           <a:xfrm>
-            <a:off x="731520" y="365760"/>
+            <a:off x="731520" y="320040"/>
             <a:ext cx="10698480" cy="365760"/>
           </a:xfrm>
           <a:prstGeom prst="rect">
@@ -3448,7 +3480,7 @@
         </p:nvSpPr>
         <p:spPr>
           <a:xfrm>
-            <a:off x="731520" y="640080"/>
+            <a:off x="731520" y="594360"/>
             <a:ext cx="10698480" cy="731520"/>
           </a:xfrm>
           <a:prstGeom prst="rect">
@@ -3463,7 +3495,7 @@
           <a:lstStyle/>
           <a:p>
             <a:pPr>
-              <a:defRPr sz="2600" b="1">
+              <a:defRPr sz="2400" b="1">
                 <a:solidFill>
                   <a:srgbClr val="FFFFFF"/>
                 </a:solidFill>
@@ -3471,7 +3503,7 @@
               </a:defRPr>
             </a:pPr>
             <a:r>
-              <a:t>AUTONEX Engine: Real-Time Distance &amp; ETA Monitoring Screen</a:t>
+              <a:t>AUTONEX Multi-Sensor Engine: Real-Time Speed, Safety &amp; Track Maintenance</a:t>
             </a:r>
           </a:p>
         </p:txBody>
@@ -3518,7 +3550,7 @@
           <a:lstStyle/>
           <a:p>
             <a:pPr algn="ctr">
-              <a:defRPr sz="1500" b="1">
+              <a:defRPr sz="1400" b="1">
                 <a:solidFill>
                   <a:srgbClr val="06B6D4"/>
                 </a:solidFill>
@@ -3526,7 +3558,7 @@
               </a:defRPr>
             </a:pPr>
             <a:r>
-              <a:t>1. Dynamic Distance &amp; Location Tracking</a:t>
+              <a:t>1. Train Speed &amp; Telemetry Sensors</a:t>
             </a:r>
           </a:p>
           <a:p>
@@ -3534,7 +3566,7 @@
               <a:spcBef>
                 <a:spcPts val="1400"/>
               </a:spcBef>
-              <a:defRPr sz="1300">
+              <a:defRPr sz="1200">
                 <a:solidFill>
                   <a:srgbClr val="FFFFFF"/>
                 </a:solidFill>
@@ -3542,15 +3574,15 @@
               </a:defRPr>
             </a:pPr>
             <a:r>
-              <a:t>• Continuous GPS + Trackside RFID Telemetry.</a:t>
+              <a:t>• Live Speed Tracking: Wheel tachometers and axle counters capture real-time train speed and acceleration profiles.</a:t>
             </a:r>
             <a:br/>
             <a:r>
-              <a:t>• Calculates exact gap (in meters) between preceding and trailing trains in real-time.</a:t>
+              <a:t>• GPS + Trackside RFID Telemetry: Calculates exact gap (in meters) between preceding and trailing trains in real-time.</a:t>
             </a:r>
             <a:br/>
             <a:r>
-              <a:t>• Provides fail-safe anti-collision distance boundary enforcement.</a:t>
+              <a:t>• Fail-Safe Anti-Collision: Enforces dynamic braking curves based on speed sensor data.</a:t>
             </a:r>
           </a:p>
         </p:txBody>
@@ -3597,7 +3629,7 @@
           <a:lstStyle/>
           <a:p>
             <a:pPr algn="ctr">
-              <a:defRPr sz="1500" b="1">
+              <a:defRPr sz="1400" b="1">
                 <a:solidFill>
                   <a:srgbClr val="10B981"/>
                 </a:solidFill>
@@ -3605,7 +3637,7 @@
               </a:defRPr>
             </a:pPr>
             <a:r>
-              <a:t>2. Live Accurate ETA Readout</a:t>
+              <a:t>2. Track Maintenance &amp; Safety Sensors</a:t>
             </a:r>
           </a:p>
           <a:p>
@@ -3613,7 +3645,7 @@
               <a:spcBef>
                 <a:spcPts val="1400"/>
               </a:spcBef>
-              <a:defRPr sz="1300">
+              <a:defRPr sz="1200">
                 <a:solidFill>
                   <a:srgbClr val="FFFFFF"/>
                 </a:solidFill>
@@ -3621,15 +3653,15 @@
               </a:defRPr>
             </a:pPr>
             <a:r>
-              <a:t>• Dynamic forecast of Expected Time of Arrival (ETA) for coaching trains displayed on screen.</a:t>
+              <a:t>• Track Performance Sensors: Strain gauges and vibration accelerometers monitor rail stress, load distribution, and ballast stability.</a:t>
             </a:r>
             <a:br/>
             <a:r>
-              <a:t>• Instant calculation of exact lost time (e.g. +18 min delay).</a:t>
+              <a:t>• Preventive Maintenance Alerts: Automatically flags track wear &amp; deformation before failures occur.</a:t>
             </a:r>
             <a:br/>
             <a:r>
-              <a:t>• Eliminates manual estimation and communication latency.</a:t>
+              <a:t>• Trackside Thermal &amp; Structural Sensors: Monitors rail temperature expansion to prevent track buckling.</a:t>
             </a:r>
           </a:p>
         </p:txBody>
@@ -3676,7 +3708,7 @@
           <a:lstStyle/>
           <a:p>
             <a:pPr algn="ctr">
-              <a:defRPr sz="1500" b="1">
+              <a:defRPr sz="1400" b="1">
                 <a:solidFill>
                   <a:srgbClr val="F59E0B"/>
                 </a:solidFill>
@@ -3684,7 +3716,7 @@
               </a:defRPr>
             </a:pPr>
             <a:r>
-              <a:t>3. Automated Signal &amp; Traffic Advisory</a:t>
+              <a:t>3. Live Accurate ETA &amp; Signal Advisory</a:t>
             </a:r>
           </a:p>
           <a:p>
@@ -3692,7 +3724,7 @@
               <a:spcBef>
                 <a:spcPts val="1400"/>
               </a:spcBef>
-              <a:defRPr sz="1300">
+              <a:defRPr sz="1200">
                 <a:solidFill>
                   <a:srgbClr val="FFFFFF"/>
                 </a:solidFill>
@@ -3700,15 +3732,15 @@
               </a:defRPr>
             </a:pPr>
             <a:r>
-              <a:t>• AI-driven algorithm recommends optimal speed profiles.</a:t>
+              <a:t>• Dynamic Forecast Readout: Instant calculation of Expected Time of Arrival (ETA) displayed live on station screens (+18 min delay recovery).</a:t>
             </a:r>
             <a:br/>
             <a:r>
-              <a:t>• Predicts potential bottlenecks 30-40 km in advance.</a:t>
+              <a:t>• AI Traffic Optimization: Recommends optimal speed recovery profiles 30-40 km in advance.</a:t>
             </a:r>
             <a:br/>
             <a:r>
-              <a:t>• Automatically coordinates with station master signaling terminals.</a:t>
+              <a:t>• Station Master Signal Sync: Seamless interlock with station signaling terminals.</a:t>
             </a:r>
           </a:p>
         </p:txBody>
@@ -3747,7 +3779,7 @@
         </p:nvSpPr>
         <p:spPr>
           <a:xfrm>
-            <a:off x="731520" y="365760"/>
+            <a:off x="731520" y="320040"/>
             <a:ext cx="10698480" cy="365760"/>
           </a:xfrm>
           <a:prstGeom prst="rect">
@@ -3783,7 +3815,7 @@
         </p:nvSpPr>
         <p:spPr>
           <a:xfrm>
-            <a:off x="731520" y="640080"/>
+            <a:off x="731520" y="594360"/>
             <a:ext cx="10698480" cy="731520"/>
           </a:xfrm>
           <a:prstGeom prst="rect">
@@ -3798,7 +3830,7 @@
           <a:lstStyle/>
           <a:p>
             <a:pPr>
-              <a:defRPr sz="2600" b="1">
+              <a:defRPr sz="2400" b="1">
                 <a:solidFill>
                   <a:srgbClr val="FFFFFF"/>
                 </a:solidFill>
@@ -3806,7 +3838,7 @@
               </a:defRPr>
             </a:pPr>
             <a:r>
-              <a:t>Scenario 1: Dynamic Speed Recovery &amp; Safe Distance Control</a:t>
+              <a:t>Scenario 1: Dynamic Speed Recovery, Sensor Safety &amp; Distance Control</a:t>
             </a:r>
           </a:p>
         </p:txBody>
@@ -3853,47 +3885,70 @@
           <a:lstStyle/>
           <a:p>
             <a:pPr algn="ctr">
-              <a:defRPr sz="1500" b="1">
+              <a:defRPr sz="1400" b="1">
                 <a:solidFill>
                   <a:srgbClr val="06B6D4"/>
                 </a:solidFill>
               </a:defRPr>
             </a:pPr>
             <a:r>
-              <a:t>SPEED BOOST WITH ZERO COLLISION RISK &amp; ACCURATE ETA</a:t>
+              <a:t>SPEED BOOST WITH MULTI-SENSOR SAFETY MANAGEMENT</a:t>
             </a:r>
           </a:p>
           <a:p>
             <a:pPr>
               <a:spcBef>
-                <a:spcPts val="1000"/>
+                <a:spcPts val="800"/>
               </a:spcBef>
             </a:pPr>
             <a:r>
-              <a:rPr b="1" sz="1300">
+              <a:rPr b="1" sz="1200">
                 <a:solidFill>
                   <a:srgbClr val="FFFFFF"/>
                 </a:solidFill>
               </a:rPr>
-              <a:t>• Trailing Coaching Train Speed Optimization:</a:t>
-            </a:r>
-            <a:r>
-              <a:rPr sz="1300">
+              <a:t>• Speed Sensor Telemetry:</a:t>
+            </a:r>
+            <a:r>
+              <a:rPr sz="1200">
                 <a:solidFill>
                   <a:srgbClr val="A0AEC0"/>
                 </a:solidFill>
               </a:rPr>
-              <a:t> If a trailing coaching train is running behind schedule, AUTONEX evaluates section limits and permits safe speed acceleration.</a:t>
+              <a:t> Speed sensors (wheel tachometers &amp; axle counters) continuously monitor train speed to ensure permissible section limit acceleration.</a:t>
             </a:r>
           </a:p>
           <a:p>
             <a:pPr>
               <a:spcBef>
-                <a:spcPts val="1000"/>
+                <a:spcPts val="800"/>
               </a:spcBef>
             </a:pPr>
             <a:r>
-              <a:rPr b="1" sz="1300">
+              <a:rPr b="1" sz="1200">
+                <a:solidFill>
+                  <a:srgbClr val="FFFFFF"/>
+                </a:solidFill>
+              </a:rPr>
+              <a:t>• Track Performance Validation:</a:t>
+            </a:r>
+            <a:r>
+              <a:rPr sz="1200">
+                <a:solidFill>
+                  <a:srgbClr val="A0AEC0"/>
+                </a:solidFill>
+              </a:rPr>
+              <a:t> Track strain and vibration sensors confirm track health stability before permitting speed recovery.</a:t>
+            </a:r>
+          </a:p>
+          <a:p>
+            <a:pPr>
+              <a:spcBef>
+                <a:spcPts val="800"/>
+              </a:spcBef>
+            </a:pPr>
+            <a:r>
+              <a:rPr b="1" sz="1200">
                 <a:solidFill>
                   <a:srgbClr val="FFFFFF"/>
                 </a:solidFill>
@@ -3901,22 +3956,22 @@
               <a:t>• Real-Time Inter-Train Gap Guard:</a:t>
             </a:r>
             <a:r>
-              <a:rPr sz="1300">
+              <a:rPr sz="1200">
                 <a:solidFill>
                   <a:srgbClr val="A0AEC0"/>
                 </a:solidFill>
               </a:rPr>
-              <a:t> Location data of both preceding and trailing trains is streamed synchronously to maintain mandatory safe braking distance.</a:t>
+              <a:t> Telemetry data of preceding and trailing trains streams synchronously to maintain mandatory safe braking distance.</a:t>
             </a:r>
           </a:p>
           <a:p>
             <a:pPr>
               <a:spcBef>
-                <a:spcPts val="1000"/>
+                <a:spcPts val="800"/>
               </a:spcBef>
             </a:pPr>
             <a:r>
-              <a:rPr b="1" sz="1300">
+              <a:rPr b="1" sz="1200">
                 <a:solidFill>
                   <a:srgbClr val="FFFFFF"/>
                 </a:solidFill>
@@ -3924,35 +3979,12 @@
               <a:t>• Collision Prevention Assurance:</a:t>
             </a:r>
             <a:r>
-              <a:rPr sz="1300">
+              <a:rPr sz="1200">
                 <a:solidFill>
                   <a:srgbClr val="A0AEC0"/>
                 </a:solidFill>
               </a:rPr>
-              <a:t> If the gap narrows below safe threshold, the engine automatically throttles back or applies controlled braking.</a:t>
-            </a:r>
-          </a:p>
-          <a:p>
-            <a:pPr>
-              <a:spcBef>
-                <a:spcPts val="1000"/>
-              </a:spcBef>
-            </a:pPr>
-            <a:r>
-              <a:rPr b="1" sz="1300">
-                <a:solidFill>
-                  <a:srgbClr val="FFFFFF"/>
-                </a:solidFill>
-              </a:rPr>
-              <a:t>• ETA Recovery &amp; Delay Mitigation:</a:t>
-            </a:r>
-            <a:r>
-              <a:rPr sz="1300">
-                <a:solidFill>
-                  <a:srgbClr val="A0AEC0"/>
-                </a:solidFill>
-              </a:rPr>
-              <a:t> Allows late trains to make up lost minutes dynamically on clear tracks without risking safety hazards.</a:t>
+              <a:t> If inter-train gap narrows below safe threshold, the system automatically throttles back or applies controlled braking.</a:t>
             </a:r>
           </a:p>
         </p:txBody>
@@ -3999,47 +4031,116 @@
           <a:lstStyle/>
           <a:p>
             <a:pPr algn="ctr">
-              <a:defRPr sz="1600" b="1">
+              <a:defRPr sz="1500" b="1">
                 <a:solidFill>
                   <a:srgbClr val="10B981"/>
                 </a:solidFill>
               </a:defRPr>
             </a:pPr>
             <a:r>
-              <a:t>AUTONEX GAP &amp; SAFETY MATRIX</a:t>
+              <a:t>AUTONEX SENSOR &amp; SAFETY MATRIX</a:t>
             </a:r>
           </a:p>
           <a:p>
             <a:pPr>
               <a:spcBef>
-                <a:spcPts val="1400"/>
+                <a:spcPts val="1000"/>
               </a:spcBef>
             </a:pPr>
             <a:r>
-              <a:rPr b="1" sz="1300">
+              <a:rPr b="1" sz="1200">
                 <a:solidFill>
                   <a:srgbClr val="FFFFFF"/>
                 </a:solidFill>
               </a:rPr>
-              <a:t>Location Telemetry:</a:t>
-            </a:r>
-            <a:r>
-              <a:rPr sz="1300">
+              <a:t>Speed Telemetry:</a:t>
+            </a:r>
+            <a:r>
+              <a:rPr sz="1200">
                 <a:solidFill>
                   <a:srgbClr val="06B6D4"/>
                 </a:solidFill>
               </a:rPr>
-              <a:t> GPS + Trackside Transponders</a:t>
+              <a:t> Wheel Tachometers + Axle Counters</a:t>
             </a:r>
           </a:p>
           <a:p>
             <a:pPr>
               <a:spcBef>
-                <a:spcPts val="1400"/>
+                <a:spcPts val="1000"/>
               </a:spcBef>
             </a:pPr>
             <a:r>
-              <a:rPr b="1" sz="1300">
+              <a:rPr b="1" sz="1200">
+                <a:solidFill>
+                  <a:srgbClr val="FFFFFF"/>
+                </a:solidFill>
+              </a:rPr>
+              <a:t>Track Maintenance:</a:t>
+            </a:r>
+            <a:r>
+              <a:rPr sz="1200">
+                <a:solidFill>
+                  <a:srgbClr val="06B6D4"/>
+                </a:solidFill>
+              </a:rPr>
+              <a:t> Strain Gauges + Vibration Sensors</a:t>
+            </a:r>
+          </a:p>
+          <a:p>
+            <a:pPr>
+              <a:spcBef>
+                <a:spcPts val="1000"/>
+              </a:spcBef>
+            </a:pPr>
+            <a:r>
+              <a:rPr b="1" sz="1200">
+                <a:solidFill>
+                  <a:srgbClr val="FFFFFF"/>
+                </a:solidFill>
+              </a:rPr>
+              <a:t>Location Tracking:</a:t>
+            </a:r>
+            <a:r>
+              <a:rPr sz="1200">
+                <a:solidFill>
+                  <a:srgbClr val="06B6D4"/>
+                </a:solidFill>
+              </a:rPr>
+              <a:t> GPS + Trackside RFID Transponders</a:t>
+            </a:r>
+          </a:p>
+          <a:p>
+            <a:pPr>
+              <a:spcBef>
+                <a:spcPts val="1000"/>
+              </a:spcBef>
+            </a:pPr>
+            <a:r>
+              <a:rPr b="1" sz="1200">
+                <a:solidFill>
+                  <a:srgbClr val="FFFFFF"/>
+                </a:solidFill>
+              </a:rPr>
+              <a:t>Gap Calculation:</a:t>
+            </a:r>
+            <a:r>
+              <a:rPr sz="1200">
+                <a:solidFill>
+                  <a:srgbClr val="06B6D4"/>
+                </a:solidFill>
+              </a:rPr>
+              <a:t> Continuous Sub-Second Delta</a:t>
+            </a:r>
+          </a:p>
+          <a:p>
+            <a:pPr>
+              <a:spcBef>
+                <a:spcPts val="1000"/>
+              </a:spcBef>
+            </a:pPr>
+            <a:r>
+              <a:rPr b="1" sz="1200">
                 <a:solidFill>
                   <a:srgbClr val="FFFFFF"/>
                 </a:solidFill>
@@ -4047,7 +4148,7 @@
               <a:t>ETA Forecast Model:</a:t>
             </a:r>
             <a:r>
-              <a:rPr sz="1300">
+              <a:rPr sz="1200">
                 <a:solidFill>
                   <a:srgbClr val="06B6D4"/>
                 </a:solidFill>
@@ -4058,57 +4159,11 @@
           <a:p>
             <a:pPr>
               <a:spcBef>
-                <a:spcPts val="1400"/>
+                <a:spcPts val="1000"/>
               </a:spcBef>
             </a:pPr>
             <a:r>
-              <a:rPr b="1" sz="1300">
-                <a:solidFill>
-                  <a:srgbClr val="FFFFFF"/>
-                </a:solidFill>
-              </a:rPr>
-              <a:t>Gap Calculation:</a:t>
-            </a:r>
-            <a:r>
-              <a:rPr sz="1300">
-                <a:solidFill>
-                  <a:srgbClr val="06B6D4"/>
-                </a:solidFill>
-              </a:rPr>
-              <a:t> Continuous Sub-Second Delta</a:t>
-            </a:r>
-          </a:p>
-          <a:p>
-            <a:pPr>
-              <a:spcBef>
-                <a:spcPts val="1400"/>
-              </a:spcBef>
-            </a:pPr>
-            <a:r>
-              <a:rPr b="1" sz="1300">
-                <a:solidFill>
-                  <a:srgbClr val="FFFFFF"/>
-                </a:solidFill>
-              </a:rPr>
-              <a:t>Speed Curve:</a:t>
-            </a:r>
-            <a:r>
-              <a:rPr sz="1300">
-                <a:solidFill>
-                  <a:srgbClr val="06B6D4"/>
-                </a:solidFill>
-              </a:rPr>
-              <a:t> AI Braking Curve Calculation</a:t>
-            </a:r>
-          </a:p>
-          <a:p>
-            <a:pPr>
-              <a:spcBef>
-                <a:spcPts val="1400"/>
-              </a:spcBef>
-            </a:pPr>
-            <a:r>
-              <a:rPr b="1" sz="1300">
+              <a:rPr b="1" sz="1200">
                 <a:solidFill>
                   <a:srgbClr val="FFFFFF"/>
                 </a:solidFill>
@@ -4116,12 +4171,12 @@
               <a:t>Collision Risk:</a:t>
             </a:r>
             <a:r>
-              <a:rPr sz="1300">
+              <a:rPr sz="1200">
                 <a:solidFill>
                   <a:srgbClr val="06B6D4"/>
                 </a:solidFill>
               </a:rPr>
-              <a:t> 0% (Fail-Safe Signal Interlock)</a:t>
+              <a:t> 0% (Fail-Safe Sensor Interlock)</a:t>
             </a:r>
           </a:p>
         </p:txBody>
@@ -4160,7 +4215,7 @@
         </p:nvSpPr>
         <p:spPr>
           <a:xfrm>
-            <a:off x="731520" y="365760"/>
+            <a:off x="731520" y="320040"/>
             <a:ext cx="10698480" cy="365760"/>
           </a:xfrm>
           <a:prstGeom prst="rect">
@@ -4196,7 +4251,7 @@
         </p:nvSpPr>
         <p:spPr>
           <a:xfrm>
-            <a:off x="731520" y="640080"/>
+            <a:off x="731520" y="594360"/>
             <a:ext cx="10698480" cy="731520"/>
           </a:xfrm>
           <a:prstGeom prst="rect">
@@ -4211,7 +4266,7 @@
           <a:lstStyle/>
           <a:p>
             <a:pPr>
-              <a:defRPr sz="2600" b="1">
+              <a:defRPr sz="2400" b="1">
                 <a:solidFill>
                   <a:srgbClr val="FFFFFF"/>
                 </a:solidFill>
@@ -4266,7 +4321,7 @@
           <a:lstStyle/>
           <a:p>
             <a:pPr algn="ctr">
-              <a:defRPr sz="1500" b="1">
+              <a:defRPr sz="1400" b="1">
                 <a:solidFill>
                   <a:srgbClr val="10B981"/>
                 </a:solidFill>
@@ -4281,14 +4336,14 @@
               <a:spcBef>
                 <a:spcPts val="600"/>
               </a:spcBef>
-              <a:defRPr sz="1300">
+              <a:defRPr sz="1200">
                 <a:solidFill>
                   <a:srgbClr val="FFFFFF"/>
                 </a:solidFill>
               </a:defRPr>
             </a:pPr>
             <a:r>
-              <a:t>• Early Distance Detection: When a Coaching train approaches a slower Freight train from behind, AUTONEX detects distance gap narrowing 20–30 minutes in advance.</a:t>
+              <a:t>• Speed &amp; Distance Gap Detection: When a Coaching train approaches a slower Freight train, AUTONEX speed sensors and gap telemetry detect closing distance 20–30 minutes in advance.</a:t>
             </a:r>
           </a:p>
           <a:p>
@@ -4296,14 +4351,14 @@
               <a:spcBef>
                 <a:spcPts val="400"/>
               </a:spcBef>
-              <a:defRPr sz="1300">
+              <a:defRPr sz="1200">
                 <a:solidFill>
                   <a:srgbClr val="A0AEC0"/>
                 </a:solidFill>
               </a:defRPr>
             </a:pPr>
             <a:r>
-              <a:t>• Seamless Shunting: The slower train is pre-routed into a loop line ahead of time without forcing abrupt braking, letting the coaching train pass effortlessly.</a:t>
+              <a:t>• Seamless Shunting: The slower freight train is pre-routed into a loop line smoothly ahead of time, allowing the coaching train to overtake effortlessly without abrupt stopping.</a:t>
             </a:r>
           </a:p>
         </p:txBody>
@@ -4350,7 +4405,7 @@
           <a:lstStyle/>
           <a:p>
             <a:pPr algn="ctr">
-              <a:defRPr sz="1500" b="1">
+              <a:defRPr sz="1400" b="1">
                 <a:solidFill>
                   <a:srgbClr val="06B6D4"/>
                 </a:solidFill>
@@ -4365,14 +4420,14 @@
               <a:spcBef>
                 <a:spcPts val="600"/>
               </a:spcBef>
-              <a:defRPr sz="1300">
+              <a:defRPr sz="1200">
                 <a:solidFill>
                   <a:srgbClr val="FFFFFF"/>
                 </a:solidFill>
               </a:defRPr>
             </a:pPr>
             <a:r>
-              <a:t>• Smart Station Halt Selection: If stopping a train at a current small station will choke the section, AUTONEX dynamically shifts its operational halt to the next station.</a:t>
+              <a:t>• Smart Station Halt Selection: If stopping a train at a congested station will choke section throughput, AUTONEX dynamically shifts operational halts to the next available station.</a:t>
             </a:r>
           </a:p>
           <a:p>
@@ -4380,14 +4435,14 @@
               <a:spcBef>
                 <a:spcPts val="400"/>
               </a:spcBef>
-              <a:defRPr sz="1300">
+              <a:defRPr sz="1200">
                 <a:solidFill>
                   <a:srgbClr val="A0AEC0"/>
                 </a:solidFill>
               </a:defRPr>
             </a:pPr>
             <a:r>
-              <a:t>• Accurate Screen Display: Exact delay time and updated ETA schedules are shown live on controller dashboard screens with zero error.</a:t>
+              <a:t>• Real-Time Controller Sync: Updated ETA schedules and track status are broadcast live to station master signaling screens.</a:t>
             </a:r>
           </a:p>
         </p:txBody>
@@ -4426,7 +4481,7 @@
         </p:nvSpPr>
         <p:spPr>
           <a:xfrm>
-            <a:off x="731520" y="365760"/>
+            <a:off x="731520" y="320040"/>
             <a:ext cx="10698480" cy="365760"/>
           </a:xfrm>
           <a:prstGeom prst="rect">
@@ -4462,7 +4517,7 @@
         </p:nvSpPr>
         <p:spPr>
           <a:xfrm>
-            <a:off x="731520" y="640080"/>
+            <a:off x="731520" y="594360"/>
             <a:ext cx="10698480" cy="731520"/>
           </a:xfrm>
           <a:prstGeom prst="rect">
@@ -4477,7 +4532,7 @@
           <a:lstStyle/>
           <a:p>
             <a:pPr>
-              <a:defRPr sz="2600" b="1">
+              <a:defRPr sz="2400" b="1">
                 <a:solidFill>
                   <a:srgbClr val="FFFFFF"/>
                 </a:solidFill>
@@ -4532,7 +4587,7 @@
           <a:lstStyle/>
           <a:p>
             <a:pPr algn="ctr">
-              <a:defRPr sz="2800" b="1">
+              <a:defRPr sz="2400" b="1">
                 <a:solidFill>
                   <a:srgbClr val="10B981"/>
                 </a:solidFill>
@@ -4545,7 +4600,7 @@
           </a:p>
           <a:p>
             <a:pPr>
-              <a:defRPr sz="1300" b="1">
+              <a:defRPr sz="1200" b="1">
                 <a:solidFill>
                   <a:srgbClr val="FFFFFF"/>
                 </a:solidFill>
@@ -4558,7 +4613,7 @@
           </a:p>
           <a:p>
             <a:pPr>
-              <a:defRPr sz="1100">
+              <a:defRPr sz="1050">
                 <a:solidFill>
                   <a:srgbClr val="A0AEC0"/>
                 </a:solidFill>
@@ -4566,7 +4621,7 @@
               </a:defRPr>
             </a:pPr>
             <a:r>
-              <a:t>Guaranteed safe gap distance &amp; automated interlock</a:t>
+              <a:t>Fail-safe speed &amp; proximity sensor interlocks</a:t>
             </a:r>
           </a:p>
         </p:txBody>
@@ -4613,7 +4668,7 @@
           <a:lstStyle/>
           <a:p>
             <a:pPr algn="ctr">
-              <a:defRPr sz="2800" b="1">
+              <a:defRPr sz="2400" b="1">
                 <a:solidFill>
                   <a:srgbClr val="06B6D4"/>
                 </a:solidFill>
@@ -4626,7 +4681,7 @@
           </a:p>
           <a:p>
             <a:pPr>
-              <a:defRPr sz="1300" b="1">
+              <a:defRPr sz="1200" b="1">
                 <a:solidFill>
                   <a:srgbClr val="FFFFFF"/>
                 </a:solidFill>
@@ -4639,7 +4694,7 @@
           </a:p>
           <a:p>
             <a:pPr>
-              <a:defRPr sz="1100">
+              <a:defRPr sz="1050">
                 <a:solidFill>
                   <a:srgbClr val="A0AEC0"/>
                 </a:solidFill>
@@ -4647,7 +4702,7 @@
               </a:defRPr>
             </a:pPr>
             <a:r>
-              <a:t>Eliminating cascading delays for express &amp; freight corridors</a:t>
+              <a:t>Eliminating cascading bottleneck delays</a:t>
             </a:r>
           </a:p>
         </p:txBody>
@@ -4694,7 +4749,7 @@
           <a:lstStyle/>
           <a:p>
             <a:pPr algn="ctr">
-              <a:defRPr sz="2800" b="1">
+              <a:defRPr sz="2400" b="1">
                 <a:solidFill>
                   <a:srgbClr val="F59E0B"/>
                 </a:solidFill>
@@ -4702,12 +4757,12 @@
               </a:defRPr>
             </a:pPr>
             <a:r>
-              <a:t>20-30 Min</a:t>
+              <a:t>Predictive</a:t>
             </a:r>
           </a:p>
           <a:p>
             <a:pPr>
-              <a:defRPr sz="1300" b="1">
+              <a:defRPr sz="1200" b="1">
                 <a:solidFill>
                   <a:srgbClr val="FFFFFF"/>
                 </a:solidFill>
@@ -4715,12 +4770,12 @@
               </a:defRPr>
             </a:pPr>
             <a:r>
-              <a:t>Advance Loop Pre-routing</a:t>
+              <a:t>Track Maintenance</a:t>
             </a:r>
           </a:p>
           <a:p>
             <a:pPr>
-              <a:defRPr sz="1100">
+              <a:defRPr sz="1050">
                 <a:solidFill>
                   <a:srgbClr val="A0AEC0"/>
                 </a:solidFill>
@@ -4728,7 +4783,7 @@
               </a:defRPr>
             </a:pPr>
             <a:r>
-              <a:t>Smooth overtake for Coaching trains without delays</a:t>
+              <a:t>Track strain &amp; vibration sensor telemetry</a:t>
             </a:r>
           </a:p>
         </p:txBody>
@@ -4775,7 +4830,7 @@
           <a:lstStyle/>
           <a:p>
             <a:pPr algn="ctr">
-              <a:defRPr sz="2800" b="1">
+              <a:defRPr sz="2400" b="1">
                 <a:solidFill>
                   <a:srgbClr val="FFFFFF"/>
                 </a:solidFill>
@@ -4788,7 +4843,7 @@
           </a:p>
           <a:p>
             <a:pPr>
-              <a:defRPr sz="1300" b="1">
+              <a:defRPr sz="1200" b="1">
                 <a:solidFill>
                   <a:srgbClr val="FFFFFF"/>
                 </a:solidFill>
@@ -4801,7 +4856,7 @@
           </a:p>
           <a:p>
             <a:pPr>
-              <a:defRPr sz="1100">
+              <a:defRPr sz="1050">
                 <a:solidFill>
                   <a:srgbClr val="A0AEC0"/>
                 </a:solidFill>
@@ -4809,7 +4864,7 @@
               </a:defRPr>
             </a:pPr>
             <a:r>
-              <a:t>Real-time delay &amp; location gap telemetry on screen</a:t>
+              <a:t>Real-time location, speed &amp; ETA on screen</a:t>
             </a:r>
           </a:p>
         </p:txBody>
@@ -4856,7 +4911,7 @@
           <a:lstStyle/>
           <a:p>
             <a:pPr algn="ctr">
-              <a:defRPr sz="1500" b="1">
+              <a:defRPr sz="1400" b="1">
                 <a:solidFill>
                   <a:srgbClr val="06B6D4"/>
                 </a:solidFill>
@@ -4871,14 +4926,14 @@
               <a:spcBef>
                 <a:spcPts val="400"/>
               </a:spcBef>
-              <a:defRPr sz="1300">
+              <a:defRPr sz="1200">
                 <a:solidFill>
                   <a:srgbClr val="FFFFFF"/>
                 </a:solidFill>
               </a:defRPr>
             </a:pPr>
             <a:r>
-              <a:t>1. Dynamic ETA Forecasting: Provides live accurate ETA predictions for coaching trains dynamically updated via telemetry.</a:t>
+              <a:t>1. Dynamic ETA Forecasting: Accurate live ETA predictions dynamically updated via multi-sensor telemetry.</a:t>
             </a:r>
           </a:p>
           <a:p>
@@ -4886,14 +4941,14 @@
               <a:spcBef>
                 <a:spcPts val="400"/>
               </a:spcBef>
-              <a:defRPr sz="1300">
+              <a:defRPr sz="1200">
                 <a:solidFill>
                   <a:srgbClr val="FFFFFF"/>
                 </a:solidFill>
               </a:defRPr>
             </a:pPr>
             <a:r>
-              <a:t>2. Fail-Safe Operations: Integrates dynamic distance gap tracking so higher speed recovery never leads to collision danger.</a:t>
+              <a:t>2. Multi-Sensor Safety Management: Speed sensors, proximity tracking, and track health monitoring ensure 0% collision and derailment risk.</a:t>
             </a:r>
           </a:p>
           <a:p>
@@ -4901,14 +4956,14 @@
               <a:spcBef>
                 <a:spcPts val="400"/>
               </a:spcBef>
-              <a:defRPr sz="1300">
+              <a:defRPr sz="1200">
                 <a:solidFill>
                   <a:srgbClr val="FFFFFF"/>
                 </a:solidFill>
               </a:defRPr>
             </a:pPr>
             <a:r>
-              <a:t>3. Maximized Track Capacity: Moves freight &amp; local trains to loop lines 20-30 mins prior, ensuring high-speed corridors stay unlocked.</a:t>
+              <a:t>3. Predictive Track Maintenance: Continuous trackside sensor telemetry detects rail strain &amp; ballast wear to prevent unscheduled track failures.</a:t>
             </a:r>
           </a:p>
           <a:p>
@@ -4916,14 +4971,14 @@
               <a:spcBef>
                 <a:spcPts val="400"/>
               </a:spcBef>
-              <a:defRPr sz="1300">
+              <a:defRPr sz="1200">
                 <a:solidFill>
                   <a:srgbClr val="FFFFFF"/>
                 </a:solidFill>
               </a:defRPr>
             </a:pPr>
             <a:r>
-              <a:t>4. Precise Live Controller Display: Shows exact train locations, inter-train distance gaps, and accurate live delay metrics on screen.</a:t>
+              <a:t>4. Optimized Section Capacity: Pre-emptively shunts slow freight trains to loop lines 20-30 mins prior, keeping high-speed corridors unlocked.</a:t>
             </a:r>
           </a:p>
         </p:txBody>

</xml_diff>